<commit_message>
Add "Amani means peace" caption to the deck's title slide
The README already explained this, but the deck and written summary
never did - not everyone judging across Africa (or internationally)
reads Swahili, so the name shouldn't require a lookup.

Co-Authored-By: Claude Sonnet 5 <noreply@anthropic.com>
</commit_message>
<xml_diff>
--- a/amani-africa-pitch-deck.pptx
+++ b/amani-africa-pitch-deck.pptx
@@ -1749,8 +1749,8 @@
         </p:nvSpPr>
         <p:spPr>
           <a:xfrm>
-            <a:off x="822960" y="3246120"/>
-            <a:ext cx="10058400" cy="548640"/>
+            <a:off x="822960" y="3429000"/>
+            <a:ext cx="7315200" cy="274320"/>
           </a:xfrm>
           <a:prstGeom prst="rect">
             <a:avLst/>
@@ -1766,14 +1766,53 @@
               <a:buNone/>
             </a:pPr>
             <a:r>
-              <a:rPr lang="en-US" sz="2000" i="1" dirty="0">
-                <a:solidFill>
-                  <a:srgbClr val="9FC9AE"/>
+              <a:rPr lang="en-US" sz="1300" i="1" dirty="0">
+                <a:solidFill>
+                  <a:srgbClr val="AFC7BB"/>
                 </a:solidFill>
                 <a:latin typeface="Calibri" pitchFamily="34" charset="0"/>
                 <a:ea typeface="Calibri" pitchFamily="34" charset="-122"/>
                 <a:cs typeface="Calibri" pitchFamily="34" charset="-120"/>
               </a:rPr>
+              <a:t>"Amani" — Swahili for peace</a:t>
+            </a:r>
+            <a:endParaRPr lang="en-US" sz="1300" dirty="0"/>
+          </a:p>
+        </p:txBody>
+      </p:sp>
+      <p:sp>
+        <p:nvSpPr>
+          <p:cNvPr id="5" name="Text 2"/>
+          <p:cNvSpPr txBox="1"/>
+          <p:nvPr/>
+        </p:nvSpPr>
+        <p:spPr>
+          <a:xfrm>
+            <a:off x="822960" y="3794760"/>
+            <a:ext cx="10058400" cy="548640"/>
+          </a:xfrm>
+          <a:prstGeom prst="rect">
+            <a:avLst/>
+          </a:prstGeom>
+          <a:noFill/>
+          <a:ln/>
+        </p:spPr>
+        <p:txBody>
+          <a:bodyPr wrap="square" lIns="0" tIns="0" rIns="0" bIns="0" rtlCol="0" anchor="ctr"/>
+          <a:lstStyle/>
+          <a:p>
+            <a:pPr algn="l" indent="0" marL="0">
+              <a:buNone/>
+            </a:pPr>
+            <a:r>
+              <a:rPr lang="en-US" sz="2000" i="1" dirty="0">
+                <a:solidFill>
+                  <a:srgbClr val="9FC9AE"/>
+                </a:solidFill>
+                <a:latin typeface="Calibri" pitchFamily="34" charset="0"/>
+                <a:ea typeface="Calibri" pitchFamily="34" charset="-122"/>
+                <a:cs typeface="Calibri" pitchFamily="34" charset="-120"/>
+              </a:rPr>
               <a:t>De-escalating nationality-based violence before it starts.</a:t>
             </a:r>
             <a:endParaRPr lang="en-US" sz="2000" dirty="0"/>
@@ -1782,13 +1821,13 @@
       </p:sp>
       <p:sp>
         <p:nvSpPr>
-          <p:cNvPr id="5" name="Shape 2"/>
+          <p:cNvPr id="6" name="Shape 3"/>
           <p:cNvSpPr/>
           <p:nvPr/>
         </p:nvSpPr>
         <p:spPr>
           <a:xfrm>
-            <a:off x="822960" y="3977640"/>
+            <a:off x="822960" y="4526280"/>
             <a:ext cx="502920" cy="36576"/>
           </a:xfrm>
           <a:prstGeom prst="rect">
@@ -1802,13 +1841,13 @@
       </p:sp>
       <p:sp>
         <p:nvSpPr>
-          <p:cNvPr id="6" name="Text 3"/>
-          <p:cNvSpPr txBox="1"/>
-          <p:nvPr/>
-        </p:nvSpPr>
-        <p:spPr>
-          <a:xfrm>
-            <a:off x="822960" y="4160520"/>
+          <p:cNvPr id="7" name="Text 4"/>
+          <p:cNvSpPr txBox="1"/>
+          <p:nvPr/>
+        </p:nvSpPr>
+        <p:spPr>
+          <a:xfrm>
+            <a:off x="822960" y="4709160"/>
             <a:ext cx="10058400" cy="457200"/>
           </a:xfrm>
           <a:prstGeom prst="rect">
@@ -1841,7 +1880,7 @@
       </p:sp>
       <p:sp>
         <p:nvSpPr>
-          <p:cNvPr id="7" name="Text 4"/>
+          <p:cNvPr id="8" name="Text 5"/>
           <p:cNvSpPr txBox="1"/>
           <p:nvPr/>
         </p:nvSpPr>

</xml_diff>